<commit_message>
update AE tutorial and lecture
</commit_message>
<xml_diff>
--- a/Lectures/05.AE/Lecture_AE.pptx
+++ b/Lectures/05.AE/Lecture_AE.pptx
@@ -3062,7 +3062,7 @@
                 </a:solidFill>
                 <a:hlinkClick r:id="rId2"/>
               </a:rPr>
-              <a:t>https://cas.sdss.org/dr18/SearchTools/sql</a:t>
+              <a:t>https://skyserver.sdss.org/dr20/SearchTools/sql</a:t>
             </a:r>
             <a:r>
               <a:rPr lang="en-US" dirty="0">
@@ -3543,10 +3543,7 @@
                 </a:pPr>
                 <a14:m>
                   <m:oMathPara xmlns:m="http://schemas.openxmlformats.org/officeDocument/2006/math">
-                    <m:oMathParaPr>
-                      <m:jc m:val="centerGroup"/>
-                    </m:oMathParaPr>
-                    <m:oMath xmlns:m="http://schemas.openxmlformats.org/officeDocument/2006/math">
+                    <m:oMath>
                       <m:r>
                         <a:rPr lang="en-US" b="0" i="1" smtClean="0">
                           <a:solidFill>
@@ -4296,10 +4293,7 @@
                   <a:pPr/>
                   <a14:m>
                     <m:oMathPara xmlns:m="http://schemas.openxmlformats.org/officeDocument/2006/math">
-                      <m:oMathParaPr>
-                        <m:jc m:val="centerGroup"/>
-                      </m:oMathParaPr>
-                      <m:oMath xmlns:m="http://schemas.openxmlformats.org/officeDocument/2006/math">
+                      <m:oMath>
                         <m:r>
                           <a:rPr lang="en-US" sz="2800" b="0" i="1" smtClean="0">
                             <a:latin typeface="Cambria Math" panose="02040503050406030204" pitchFamily="18" charset="0"/>
@@ -4924,8 +4918,8 @@
           </p:txBody>
         </p:sp>
       </p:grpSp>
-      <mc:AlternateContent xmlns:mc="http://schemas.openxmlformats.org/markup-compatibility/2006" xmlns:a14="http://schemas.microsoft.com/office/drawing/2010/main">
-        <mc:Choice Requires="a14">
+      <mc:AlternateContent xmlns:mc="http://schemas.openxmlformats.org/markup-compatibility/2006">
+        <mc:Choice xmlns:a14="http://schemas.microsoft.com/office/drawing/2010/main" Requires="a14">
           <p:sp>
             <p:nvSpPr>
               <p:cNvPr id="17" name="TextBox 16">
@@ -4941,7 +4935,7 @@
             <p:spPr>
               <a:xfrm>
                 <a:off x="6629400" y="3134380"/>
-                <a:ext cx="2080698" cy="523220"/>
+                <a:ext cx="1885068" cy="523220"/>
               </a:xfrm>
               <a:prstGeom prst="rect">
                 <a:avLst/>
@@ -4957,10 +4951,7 @@
                 <a:pPr/>
                 <a14:m>
                   <m:oMathPara xmlns:m="http://schemas.openxmlformats.org/officeDocument/2006/math">
-                    <m:oMathParaPr>
-                      <m:jc m:val="centerGroup"/>
-                    </m:oMathParaPr>
-                    <m:oMath xmlns:m="http://schemas.openxmlformats.org/officeDocument/2006/math">
+                    <m:oMath>
                       <m:r>
                         <a:rPr lang="en-US" sz="2800" b="1" i="1" smtClean="0">
                           <a:solidFill>
@@ -4979,15 +4970,40 @@
                         </a:rPr>
                         <m:t>=</m:t>
                       </m:r>
-                      <m:r>
-                        <a:rPr lang="en-US" sz="2800" b="1" i="1" smtClean="0">
-                          <a:solidFill>
-                            <a:srgbClr val="0033CC"/>
-                          </a:solidFill>
-                          <a:latin typeface="Cambria Math" panose="02040503050406030204" pitchFamily="18" charset="0"/>
-                        </a:rPr>
-                        <m:t>𝒉</m:t>
-                      </m:r>
+                      <m:sSub>
+                        <m:sSubPr>
+                          <m:ctrlPr>
+                            <a:rPr lang="en-US" sz="2800" b="1" i="1" smtClean="0">
+                              <a:solidFill>
+                                <a:srgbClr val="0033CC"/>
+                              </a:solidFill>
+                              <a:latin typeface="Cambria Math" panose="02040503050406030204" pitchFamily="18" charset="0"/>
+                            </a:rPr>
+                          </m:ctrlPr>
+                        </m:sSubPr>
+                        <m:e>
+                          <m:r>
+                            <a:rPr lang="en-US" sz="2800" b="1" i="1" smtClean="0">
+                              <a:solidFill>
+                                <a:srgbClr val="0033CC"/>
+                              </a:solidFill>
+                              <a:latin typeface="Cambria Math" panose="02040503050406030204" pitchFamily="18" charset="0"/>
+                            </a:rPr>
+                            <m:t>𝒉</m:t>
+                          </m:r>
+                        </m:e>
+                        <m:sub>
+                          <m:r>
+                            <a:rPr lang="en-US" sz="2800" b="1" i="1" smtClean="0">
+                              <a:solidFill>
+                                <a:srgbClr val="0033CC"/>
+                              </a:solidFill>
+                              <a:latin typeface="Cambria Math" panose="02040503050406030204" pitchFamily="18" charset="0"/>
+                            </a:rPr>
+                            <m:t>𝝎</m:t>
+                          </m:r>
+                        </m:sub>
+                      </m:sSub>
                       <m:r>
                         <a:rPr lang="en-US" sz="2800" b="1" i="1" smtClean="0">
                           <a:solidFill>
@@ -5013,24 +5029,6 @@
                           </a:solidFill>
                           <a:latin typeface="Cambria Math" panose="02040503050406030204" pitchFamily="18" charset="0"/>
                         </a:rPr>
-                        <m:t>, </m:t>
-                      </m:r>
-                      <m:r>
-                        <a:rPr lang="en-US" sz="2800" b="1" i="1" smtClean="0">
-                          <a:solidFill>
-                            <a:srgbClr val="0033CC"/>
-                          </a:solidFill>
-                          <a:latin typeface="Cambria Math" panose="02040503050406030204" pitchFamily="18" charset="0"/>
-                        </a:rPr>
-                        <m:t>𝝎</m:t>
-                      </m:r>
-                      <m:r>
-                        <a:rPr lang="en-US" sz="2800" b="1" i="1" smtClean="0">
-                          <a:solidFill>
-                            <a:srgbClr val="0033CC"/>
-                          </a:solidFill>
-                          <a:latin typeface="Cambria Math" panose="02040503050406030204" pitchFamily="18" charset="0"/>
-                        </a:rPr>
                         <m:t>)</m:t>
                       </m:r>
                     </m:oMath>
@@ -5045,7 +5043,7 @@
             </p:txBody>
           </p:sp>
         </mc:Choice>
-        <mc:Fallback xmlns="">
+        <mc:Fallback>
           <p:sp>
             <p:nvSpPr>
               <p:cNvPr id="17" name="TextBox 16">
@@ -5063,7 +5061,7 @@
             <p:spPr>
               <a:xfrm>
                 <a:off x="6629400" y="3134380"/>
-                <a:ext cx="2080698" cy="523220"/>
+                <a:ext cx="1885068" cy="523220"/>
               </a:xfrm>
               <a:prstGeom prst="rect">
                 <a:avLst/>
@@ -5071,7 +5069,7 @@
               <a:blipFill>
                 <a:blip r:embed="rId5"/>
                 <a:stretch>
-                  <a:fillRect r="-1220" b="-21429"/>
+                  <a:fillRect r="-671" b="-21429"/>
                 </a:stretch>
               </a:blipFill>
             </p:spPr>
@@ -5247,10 +5245,7 @@
                 </a:pPr>
                 <a14:m>
                   <m:oMathPara xmlns:m="http://schemas.openxmlformats.org/officeDocument/2006/math">
-                    <m:oMathParaPr>
-                      <m:jc m:val="centerGroup"/>
-                    </m:oMathParaPr>
-                    <m:oMath xmlns:m="http://schemas.openxmlformats.org/officeDocument/2006/math">
+                    <m:oMath>
                       <m:r>
                         <a:rPr lang="en-US" b="0" i="1" smtClean="0">
                           <a:solidFill>
@@ -5479,9 +5474,9 @@
         <p:grpSpPr>
           <a:xfrm>
             <a:off x="2057400" y="2309156"/>
-            <a:ext cx="7036654" cy="4167844"/>
+            <a:ext cx="6841024" cy="4167844"/>
             <a:chOff x="1295400" y="2237926"/>
-            <a:chExt cx="7036654" cy="4167844"/>
+            <a:chExt cx="6841024" cy="4167844"/>
           </a:xfrm>
         </p:grpSpPr>
         <p:grpSp>
@@ -5965,8 +5960,8 @@
             </a:prstGeom>
           </p:spPr>
         </p:pic>
-        <mc:AlternateContent xmlns:mc="http://schemas.openxmlformats.org/markup-compatibility/2006" xmlns:a14="http://schemas.microsoft.com/office/drawing/2010/main">
-          <mc:Choice Requires="a14">
+        <mc:AlternateContent xmlns:mc="http://schemas.openxmlformats.org/markup-compatibility/2006">
+          <mc:Choice xmlns:a14="http://schemas.microsoft.com/office/drawing/2010/main" Requires="a14">
             <p:sp>
               <p:nvSpPr>
                 <p:cNvPr id="24" name="TextBox 23">
@@ -5982,7 +5977,7 @@
               <p:spPr>
                 <a:xfrm>
                   <a:off x="6235326" y="3052970"/>
-                  <a:ext cx="2096728" cy="523220"/>
+                  <a:ext cx="1901098" cy="523220"/>
                 </a:xfrm>
                 <a:prstGeom prst="rect">
                   <a:avLst/>
@@ -5998,10 +5993,7 @@
                   <a:pPr/>
                   <a14:m>
                     <m:oMathPara xmlns:m="http://schemas.openxmlformats.org/officeDocument/2006/math">
-                      <m:oMathParaPr>
-                        <m:jc m:val="centerGroup"/>
-                      </m:oMathParaPr>
-                      <m:oMath xmlns:m="http://schemas.openxmlformats.org/officeDocument/2006/math">
+                      <m:oMath>
                         <m:r>
                           <a:rPr lang="en-US" sz="2800" b="1" i="1" smtClean="0">
                             <a:solidFill>
@@ -6020,15 +6012,40 @@
                           </a:rPr>
                           <m:t>=</m:t>
                         </m:r>
-                        <m:r>
-                          <a:rPr lang="en-US" sz="2800" b="1" i="1" smtClean="0">
-                            <a:solidFill>
-                              <a:srgbClr val="C00000"/>
-                            </a:solidFill>
-                            <a:latin typeface="Cambria Math" panose="02040503050406030204" pitchFamily="18" charset="0"/>
-                          </a:rPr>
-                          <m:t>𝒈</m:t>
-                        </m:r>
+                        <m:sSub>
+                          <m:sSubPr>
+                            <m:ctrlPr>
+                              <a:rPr lang="en-US" sz="2800" b="1" i="1" smtClean="0">
+                                <a:solidFill>
+                                  <a:srgbClr val="C00000"/>
+                                </a:solidFill>
+                                <a:latin typeface="Cambria Math" panose="02040503050406030204" pitchFamily="18" charset="0"/>
+                              </a:rPr>
+                            </m:ctrlPr>
+                          </m:sSubPr>
+                          <m:e>
+                            <m:r>
+                              <a:rPr lang="en-US" sz="2800" b="1" i="1" smtClean="0">
+                                <a:solidFill>
+                                  <a:srgbClr val="C00000"/>
+                                </a:solidFill>
+                                <a:latin typeface="Cambria Math" panose="02040503050406030204" pitchFamily="18" charset="0"/>
+                              </a:rPr>
+                              <m:t>𝒈</m:t>
+                            </m:r>
+                          </m:e>
+                          <m:sub>
+                            <m:r>
+                              <a:rPr lang="en-US" sz="2800" b="1" i="1" smtClean="0">
+                                <a:solidFill>
+                                  <a:srgbClr val="C00000"/>
+                                </a:solidFill>
+                                <a:latin typeface="Cambria Math" panose="02040503050406030204" pitchFamily="18" charset="0"/>
+                              </a:rPr>
+                              <m:t>𝝎</m:t>
+                            </m:r>
+                          </m:sub>
+                        </m:sSub>
                         <m:r>
                           <a:rPr lang="en-US" sz="2800" b="1" i="1" smtClean="0">
                             <a:solidFill>
@@ -6054,24 +6071,6 @@
                             </a:solidFill>
                             <a:latin typeface="Cambria Math" panose="02040503050406030204" pitchFamily="18" charset="0"/>
                           </a:rPr>
-                          <m:t>, </m:t>
-                        </m:r>
-                        <m:r>
-                          <a:rPr lang="en-US" sz="2800" b="1" i="1" smtClean="0">
-                            <a:solidFill>
-                              <a:srgbClr val="C00000"/>
-                            </a:solidFill>
-                            <a:latin typeface="Cambria Math" panose="02040503050406030204" pitchFamily="18" charset="0"/>
-                          </a:rPr>
-                          <m:t>𝝎</m:t>
-                        </m:r>
-                        <m:r>
-                          <a:rPr lang="en-US" sz="2800" b="1" i="1" smtClean="0">
-                            <a:solidFill>
-                              <a:srgbClr val="C00000"/>
-                            </a:solidFill>
-                            <a:latin typeface="Cambria Math" panose="02040503050406030204" pitchFamily="18" charset="0"/>
-                          </a:rPr>
                           <m:t>)</m:t>
                         </m:r>
                       </m:oMath>
@@ -6086,7 +6085,7 @@
               </p:txBody>
             </p:sp>
           </mc:Choice>
-          <mc:Fallback xmlns="">
+          <mc:Fallback>
             <p:sp>
               <p:nvSpPr>
                 <p:cNvPr id="24" name="TextBox 23">
@@ -6104,7 +6103,7 @@
               <p:spPr>
                 <a:xfrm>
                   <a:off x="6235326" y="3052970"/>
-                  <a:ext cx="2096728" cy="523220"/>
+                  <a:ext cx="1901098" cy="523220"/>
                 </a:xfrm>
                 <a:prstGeom prst="rect">
                   <a:avLst/>
@@ -6112,7 +6111,7 @@
                 <a:blipFill>
                   <a:blip r:embed="rId4"/>
                   <a:stretch>
-                    <a:fillRect r="-602" b="-19048"/>
+                    <a:fillRect r="-1333" b="-19048"/>
                   </a:stretch>
                 </a:blipFill>
               </p:spPr>
@@ -6164,10 +6163,7 @@
                   <a:pPr/>
                   <a14:m>
                     <m:oMathPara xmlns:m="http://schemas.openxmlformats.org/officeDocument/2006/math">
-                      <m:oMathParaPr>
-                        <m:jc m:val="centerGroup"/>
-                      </m:oMathParaPr>
-                      <m:oMath xmlns:m="http://schemas.openxmlformats.org/officeDocument/2006/math">
+                      <m:oMath>
                         <m:r>
                           <a:rPr lang="en-US" sz="2800" b="0" i="1" smtClean="0">
                             <a:latin typeface="Cambria Math" panose="02040503050406030204" pitchFamily="18" charset="0"/>
@@ -7270,8 +7266,8 @@
           <a:chExt cx="0" cy="0"/>
         </a:xfrm>
       </p:grpSpPr>
-      <mc:AlternateContent xmlns:mc="http://schemas.openxmlformats.org/markup-compatibility/2006" xmlns:a14="http://schemas.microsoft.com/office/drawing/2010/main">
-        <mc:Choice Requires="a14">
+      <mc:AlternateContent xmlns:mc="http://schemas.openxmlformats.org/markup-compatibility/2006">
+        <mc:Choice xmlns:a14="http://schemas.microsoft.com/office/drawing/2010/main" Requires="a14">
           <p:sp>
             <p:nvSpPr>
               <p:cNvPr id="2" name="Content Placeholder 1" descr="xxx">
@@ -7319,7 +7315,7 @@
                     <m:sSub>
                       <m:sSubPr>
                         <m:ctrlPr>
-                          <a:rPr lang="en-US" b="0" i="1" smtClean="0">
+                          <a:rPr lang="en-US" i="1">
                             <a:solidFill>
                               <a:srgbClr val="0033CC"/>
                             </a:solidFill>
@@ -7354,13 +7350,13 @@
                 </a14:m>
                 <a:r>
                   <a:rPr lang="en-US" dirty="0"/>
-                  <a:t> the predicted flux. As anticipated, the autoencoder seems to provide an unbiased estimate of the flux.</a:t>
+                  <a:t> the predicted flux. As anticipated, the bias in the autoencoder is small.</a:t>
                 </a:r>
               </a:p>
             </p:txBody>
           </p:sp>
         </mc:Choice>
-        <mc:Fallback xmlns="">
+        <mc:Fallback>
           <p:sp>
             <p:nvSpPr>
               <p:cNvPr id="2" name="Content Placeholder 1" descr="xxx">
@@ -7600,7 +7596,47 @@
           <a:p>
             <a:r>
               <a:rPr lang="en-US" dirty="0"/>
-              <a:t>A convolutional autoencoder is simply an autoencoder that operates on 2-dimensional data, such as images.</a:t>
+              <a:t>A </a:t>
+            </a:r>
+            <a:r>
+              <a:rPr lang="en-US" b="1" dirty="0">
+                <a:solidFill>
+                  <a:srgbClr val="0033CC"/>
+                </a:solidFill>
+              </a:rPr>
+              <a:t>C</a:t>
+            </a:r>
+            <a:r>
+              <a:rPr lang="en-US" dirty="0"/>
+              <a:t>onvolutional </a:t>
+            </a:r>
+            <a:r>
+              <a:rPr lang="en-US" b="1" dirty="0" err="1">
+                <a:solidFill>
+                  <a:srgbClr val="0033CC"/>
+                </a:solidFill>
+              </a:rPr>
+              <a:t>A</a:t>
+            </a:r>
+            <a:r>
+              <a:rPr lang="en-US" dirty="0" err="1"/>
+              <a:t>uto</a:t>
+            </a:r>
+            <a:r>
+              <a:rPr lang="en-US" b="1" dirty="0" err="1">
+                <a:solidFill>
+                  <a:srgbClr val="0033CC"/>
+                </a:solidFill>
+              </a:rPr>
+              <a:t>E</a:t>
+            </a:r>
+            <a:r>
+              <a:rPr lang="en-US" dirty="0" err="1"/>
+              <a:t>ncoder</a:t>
+            </a:r>
+            <a:r>
+              <a:rPr lang="en-US" dirty="0"/>
+              <a:t> is an autoencoder that operates on 2-dimensional data, such as images.</a:t>
             </a:r>
           </a:p>
           <a:p>
@@ -8620,45 +8656,129 @@
           </a:p>
         </p:txBody>
       </p:sp>
-      <p:sp>
-        <p:nvSpPr>
-          <p:cNvPr id="83" name="TextBox 82">
-            <a:extLst>
-              <a:ext uri="{FF2B5EF4-FFF2-40B4-BE49-F238E27FC236}">
-                <a16:creationId xmlns:a16="http://schemas.microsoft.com/office/drawing/2014/main" id="{66153096-9EA7-ACAE-5289-118D7E8EFA1B}"/>
-              </a:ext>
-            </a:extLst>
-          </p:cNvPr>
-          <p:cNvSpPr txBox="1"/>
-          <p:nvPr/>
-        </p:nvSpPr>
-        <p:spPr>
-          <a:xfrm>
-            <a:off x="4018431" y="2209800"/>
-            <a:ext cx="1851789" cy="461665"/>
-          </a:xfrm>
-          <a:prstGeom prst="rect">
-            <a:avLst/>
-          </a:prstGeom>
-          <a:noFill/>
-        </p:spPr>
-        <p:txBody>
-          <a:bodyPr wrap="none" rtlCol="0">
-            <a:spAutoFit/>
-          </a:bodyPr>
-          <a:lstStyle/>
-          <a:p>
-            <a:r>
-              <a:rPr lang="en-US" b="1" dirty="0">
-                <a:solidFill>
-                  <a:srgbClr val="0033CC"/>
-                </a:solidFill>
-              </a:rPr>
-              <a:t>Latent space</a:t>
-            </a:r>
-          </a:p>
-        </p:txBody>
-      </p:sp>
+      <mc:AlternateContent xmlns:mc="http://schemas.openxmlformats.org/markup-compatibility/2006">
+        <mc:Choice xmlns:a14="http://schemas.microsoft.com/office/drawing/2010/main" Requires="a14">
+          <p:sp>
+            <p:nvSpPr>
+              <p:cNvPr id="83" name="TextBox 82">
+                <a:extLst>
+                  <a:ext uri="{FF2B5EF4-FFF2-40B4-BE49-F238E27FC236}">
+                    <a16:creationId xmlns:a16="http://schemas.microsoft.com/office/drawing/2014/main" id="{66153096-9EA7-ACAE-5289-118D7E8EFA1B}"/>
+                  </a:ext>
+                </a:extLst>
+              </p:cNvPr>
+              <p:cNvSpPr txBox="1"/>
+              <p:nvPr/>
+            </p:nvSpPr>
+            <p:spPr>
+              <a:xfrm>
+                <a:off x="4018431" y="2209800"/>
+                <a:ext cx="3080715" cy="461665"/>
+              </a:xfrm>
+              <a:prstGeom prst="rect">
+                <a:avLst/>
+              </a:prstGeom>
+              <a:noFill/>
+            </p:spPr>
+            <p:txBody>
+              <a:bodyPr wrap="none" rtlCol="0">
+                <a:spAutoFit/>
+              </a:bodyPr>
+              <a:lstStyle/>
+              <a:p>
+                <a:r>
+                  <a:rPr lang="en-US" b="1" dirty="0">
+                    <a:solidFill>
+                      <a:srgbClr val="0033CC"/>
+                    </a:solidFill>
+                  </a:rPr>
+                  <a:t>Latent space </a:t>
+                </a:r>
+                <a14:m>
+                  <m:oMath xmlns:m="http://schemas.openxmlformats.org/officeDocument/2006/math">
+                    <m:r>
+                      <a:rPr lang="en-US" b="1" i="1" smtClean="0">
+                        <a:solidFill>
+                          <a:srgbClr val="0033CC"/>
+                        </a:solidFill>
+                        <a:latin typeface="Cambria Math" panose="02040503050406030204" pitchFamily="18" charset="0"/>
+                      </a:rPr>
+                      <m:t>𝒏</m:t>
+                    </m:r>
+                    <m:r>
+                      <a:rPr lang="en-US" b="1" i="1" smtClean="0">
+                        <a:solidFill>
+                          <a:srgbClr val="0033CC"/>
+                        </a:solidFill>
+                        <a:latin typeface="Cambria Math" panose="02040503050406030204" pitchFamily="18" charset="0"/>
+                      </a:rPr>
+                      <m:t>=</m:t>
+                    </m:r>
+                    <m:r>
+                      <a:rPr lang="en-US" b="1" i="1" smtClean="0">
+                        <a:solidFill>
+                          <a:srgbClr val="0033CC"/>
+                        </a:solidFill>
+                        <a:latin typeface="Cambria Math" panose="02040503050406030204" pitchFamily="18" charset="0"/>
+                      </a:rPr>
+                      <m:t>𝟓𝟕𝟔</m:t>
+                    </m:r>
+                  </m:oMath>
+                </a14:m>
+                <a:endParaRPr lang="en-US" b="1" dirty="0">
+                  <a:solidFill>
+                    <a:srgbClr val="0033CC"/>
+                  </a:solidFill>
+                </a:endParaRPr>
+              </a:p>
+            </p:txBody>
+          </p:sp>
+        </mc:Choice>
+        <mc:Fallback>
+          <p:sp>
+            <p:nvSpPr>
+              <p:cNvPr id="83" name="TextBox 82">
+                <a:extLst>
+                  <a:ext uri="{FF2B5EF4-FFF2-40B4-BE49-F238E27FC236}">
+                    <a16:creationId xmlns:a16="http://schemas.microsoft.com/office/drawing/2014/main" id="{66153096-9EA7-ACAE-5289-118D7E8EFA1B}"/>
+                  </a:ext>
+                </a:extLst>
+              </p:cNvPr>
+              <p:cNvSpPr txBox="1">
+                <a:spLocks noRot="1" noChangeAspect="1" noMove="1" noResize="1" noEditPoints="1" noAdjustHandles="1" noChangeArrowheads="1" noChangeShapeType="1" noTextEdit="1"/>
+              </p:cNvSpPr>
+              <p:nvPr/>
+            </p:nvSpPr>
+            <p:spPr>
+              <a:xfrm>
+                <a:off x="4018431" y="2209800"/>
+                <a:ext cx="3080715" cy="461665"/>
+              </a:xfrm>
+              <a:prstGeom prst="rect">
+                <a:avLst/>
+              </a:prstGeom>
+              <a:blipFill>
+                <a:blip r:embed="rId2"/>
+                <a:stretch>
+                  <a:fillRect l="-3279" t="-13514" b="-29730"/>
+                </a:stretch>
+              </a:blipFill>
+            </p:spPr>
+            <p:txBody>
+              <a:bodyPr/>
+              <a:lstStyle/>
+              <a:p>
+                <a:r>
+                  <a:rPr lang="en-US">
+                    <a:noFill/>
+                  </a:rPr>
+                  <a:t> </a:t>
+                </a:r>
+              </a:p>
+            </p:txBody>
+          </p:sp>
+        </mc:Fallback>
+      </mc:AlternateContent>
       <p:grpSp>
         <p:nvGrpSpPr>
           <p:cNvPr id="84" name="Group 83">
@@ -8674,9 +8794,9 @@
         <p:grpSpPr>
           <a:xfrm>
             <a:off x="705193" y="1447800"/>
-            <a:ext cx="4647173" cy="436955"/>
+            <a:ext cx="4809076" cy="436955"/>
             <a:chOff x="705193" y="1589668"/>
-            <a:chExt cx="4647173" cy="436955"/>
+            <a:chExt cx="4809076" cy="436955"/>
           </a:xfrm>
         </p:grpSpPr>
         <p:sp>
@@ -8764,7 +8884,7 @@
           <p:spPr>
             <a:xfrm>
               <a:off x="1148971" y="1589668"/>
-              <a:ext cx="4203395" cy="415498"/>
+              <a:ext cx="4365298" cy="415498"/>
             </a:xfrm>
             <a:prstGeom prst="rect">
               <a:avLst/>
@@ -9796,8 +9916,8 @@
           </a:p>
         </p:txBody>
       </p:sp>
-      <mc:AlternateContent xmlns:mc="http://schemas.openxmlformats.org/markup-compatibility/2006" xmlns:a14="http://schemas.microsoft.com/office/drawing/2010/main">
-        <mc:Choice Requires="a14">
+      <mc:AlternateContent xmlns:mc="http://schemas.openxmlformats.org/markup-compatibility/2006">
+        <mc:Choice xmlns:a14="http://schemas.microsoft.com/office/drawing/2010/main" Requires="a14">
           <p:sp>
             <p:nvSpPr>
               <p:cNvPr id="8" name="Content Placeholder 7">
@@ -9951,7 +10071,7 @@
                             <a:latin typeface="Cambria Math" panose="02040503050406030204" pitchFamily="18" charset="0"/>
                             <a:ea typeface="Cambria Math" panose="02040503050406030204" pitchFamily="18" charset="0"/>
                           </a:rPr>
-                          <m:t>𝑁</m:t>
+                          <m:t>𝑑</m:t>
                         </m:r>
                       </m:sup>
                     </m:sSup>
@@ -10050,7 +10170,7 @@
                         <a:latin typeface="Cambria Math" panose="02040503050406030204" pitchFamily="18" charset="0"/>
                         <a:ea typeface="Cambria Math" panose="02040503050406030204" pitchFamily="18" charset="0"/>
                       </a:rPr>
-                      <m:t>h</m:t>
+                      <m:t>ℎ</m:t>
                     </m:r>
                     <m:r>
                       <a:rPr lang="en-US" b="0" i="1" smtClean="0">
@@ -10104,7 +10224,7 @@
                         </a:solidFill>
                         <a:latin typeface="Cambria Math" panose="02040503050406030204" pitchFamily="18" charset="0"/>
                       </a:rPr>
-                      <m:t>h</m:t>
+                      <m:t>ℎ</m:t>
                     </m:r>
                     <m:r>
                       <a:rPr lang="en-US" b="0" i="1" smtClean="0">
@@ -10149,7 +10269,7 @@
                         </a:solidFill>
                         <a:latin typeface="Cambria Math" panose="02040503050406030204" pitchFamily="18" charset="0"/>
                       </a:rPr>
-                      <m:t>,  </m:t>
+                      <m:t>, </m:t>
                     </m:r>
                     <m:r>
                       <a:rPr lang="en-US" b="0" i="1" smtClean="0">
@@ -10158,52 +10278,7 @@
                         </a:solidFill>
                         <a:latin typeface="Cambria Math" panose="02040503050406030204" pitchFamily="18" charset="0"/>
                       </a:rPr>
-                      <m:t>𝑔</m:t>
-                    </m:r>
-                    <m:r>
-                      <a:rPr lang="en-US" i="1">
-                        <a:solidFill>
-                          <a:srgbClr val="0033CC"/>
-                        </a:solidFill>
-                        <a:latin typeface="Cambria Math" panose="02040503050406030204" pitchFamily="18" charset="0"/>
-                      </a:rPr>
-                      <m:t>:</m:t>
-                    </m:r>
-                    <m:r>
-                      <a:rPr lang="en-US" i="1">
-                        <a:solidFill>
-                          <a:srgbClr val="0033CC"/>
-                        </a:solidFill>
-                        <a:latin typeface="Cambria Math" panose="02040503050406030204" pitchFamily="18" charset="0"/>
-                      </a:rPr>
-                      <m:t>𝑧</m:t>
-                    </m:r>
-                    <m:r>
-                      <a:rPr lang="en-US" i="1">
-                        <a:solidFill>
-                          <a:srgbClr val="0033CC"/>
-                        </a:solidFill>
-                        <a:latin typeface="Cambria Math" panose="02040503050406030204" pitchFamily="18" charset="0"/>
-                      </a:rPr>
-                      <m:t>→</m:t>
-                    </m:r>
-                    <m:r>
-                      <a:rPr lang="en-US" i="1">
-                        <a:solidFill>
-                          <a:srgbClr val="0033CC"/>
-                        </a:solidFill>
-                        <a:latin typeface="Cambria Math" panose="02040503050406030204" pitchFamily="18" charset="0"/>
-                      </a:rPr>
-                      <m:t>𝑥</m:t>
-                    </m:r>
-                    <m:r>
-                      <a:rPr lang="en-US" i="1">
-                        <a:solidFill>
-                          <a:srgbClr val="0033CC"/>
-                        </a:solidFill>
-                        <a:latin typeface="Cambria Math" panose="02040503050406030204" pitchFamily="18" charset="0"/>
-                      </a:rPr>
-                      <m:t>,    </m:t>
+                      <m:t> </m:t>
                     </m:r>
                     <m:r>
                       <a:rPr lang="en-US" i="1">
@@ -10262,6 +10337,68 @@
                     </m:sSup>
                   </m:oMath>
                 </a14:m>
+                <a:r>
+                  <a:rPr lang="en-US" dirty="0"/>
+                  <a:t> followed by </a:t>
+                </a:r>
+                <a14:m>
+                  <m:oMath xmlns:m="http://schemas.openxmlformats.org/officeDocument/2006/math">
+                    <m:r>
+                      <a:rPr lang="en-US" i="1">
+                        <a:solidFill>
+                          <a:srgbClr val="0033CC"/>
+                        </a:solidFill>
+                        <a:latin typeface="Cambria Math" panose="02040503050406030204" pitchFamily="18" charset="0"/>
+                      </a:rPr>
+                      <m:t>𝑔</m:t>
+                    </m:r>
+                    <m:r>
+                      <a:rPr lang="en-US" i="1">
+                        <a:solidFill>
+                          <a:srgbClr val="0033CC"/>
+                        </a:solidFill>
+                        <a:latin typeface="Cambria Math" panose="02040503050406030204" pitchFamily="18" charset="0"/>
+                      </a:rPr>
+                      <m:t>:</m:t>
+                    </m:r>
+                    <m:r>
+                      <a:rPr lang="en-US" i="1">
+                        <a:solidFill>
+                          <a:srgbClr val="0033CC"/>
+                        </a:solidFill>
+                        <a:latin typeface="Cambria Math" panose="02040503050406030204" pitchFamily="18" charset="0"/>
+                      </a:rPr>
+                      <m:t>𝑧</m:t>
+                    </m:r>
+                    <m:r>
+                      <a:rPr lang="en-US" i="1">
+                        <a:solidFill>
+                          <a:srgbClr val="0033CC"/>
+                        </a:solidFill>
+                        <a:latin typeface="Cambria Math" panose="02040503050406030204" pitchFamily="18" charset="0"/>
+                      </a:rPr>
+                      <m:t>→</m:t>
+                    </m:r>
+                    <m:r>
+                      <a:rPr lang="en-US" i="1">
+                        <a:solidFill>
+                          <a:srgbClr val="0033CC"/>
+                        </a:solidFill>
+                        <a:latin typeface="Cambria Math" panose="02040503050406030204" pitchFamily="18" charset="0"/>
+                      </a:rPr>
+                      <m:t>𝑥</m:t>
+                    </m:r>
+                    <m:r>
+                      <a:rPr lang="en-US" i="1">
+                        <a:solidFill>
+                          <a:srgbClr val="0033CC"/>
+                        </a:solidFill>
+                        <a:latin typeface="Cambria Math" panose="02040503050406030204" pitchFamily="18" charset="0"/>
+                      </a:rPr>
+                      <m:t> </m:t>
+                    </m:r>
+                  </m:oMath>
+                </a14:m>
                 <a:endParaRPr lang="en-US" dirty="0"/>
               </a:p>
               <a:p>
@@ -10270,7 +10407,7 @@
                 </a:pPr>
                 <a:r>
                   <a:rPr lang="en-US" dirty="0"/>
-                  <a:t>     or		</a:t>
+                  <a:t>  	that is, 		</a:t>
                 </a:r>
                 <a:r>
                   <a:rPr lang="en-US" dirty="0">
@@ -10307,7 +10444,7 @@
                         </a:solidFill>
                         <a:latin typeface="Cambria Math" panose="02040503050406030204" pitchFamily="18" charset="0"/>
                       </a:rPr>
-                      <m:t>h</m:t>
+                      <m:t>ℎ</m:t>
                     </m:r>
                     <m:r>
                       <a:rPr lang="en-US" b="0" i="1" smtClean="0">
@@ -10340,12 +10477,12 @@
                 </a14:m>
                 <a:r>
                   <a:rPr lang="en-US" dirty="0"/>
-                  <a:t>, </a:t>
+                  <a:t> followed by </a:t>
                 </a:r>
                 <a14:m>
                   <m:oMath xmlns:m="http://schemas.openxmlformats.org/officeDocument/2006/math">
                     <m:r>
-                      <a:rPr lang="en-US" b="0" i="1" smtClean="0">
+                      <a:rPr lang="en-US" i="1">
                         <a:solidFill>
                           <a:srgbClr val="0033CC"/>
                         </a:solidFill>
@@ -10363,7 +10500,7 @@
                       <m:t>=</m:t>
                     </m:r>
                     <m:r>
-                      <a:rPr lang="en-US" b="0" i="1" smtClean="0">
+                      <a:rPr lang="en-US" i="1">
                         <a:solidFill>
                           <a:srgbClr val="0033CC"/>
                         </a:solidFill>
@@ -10381,7 +10518,7 @@
                       <m:t>(</m:t>
                     </m:r>
                     <m:r>
-                      <a:rPr lang="en-US" b="0" i="1" smtClean="0">
+                      <a:rPr lang="en-US" i="1">
                         <a:solidFill>
                           <a:srgbClr val="0033CC"/>
                         </a:solidFill>
@@ -10400,10 +10537,6 @@
                     </m:r>
                   </m:oMath>
                 </a14:m>
-                <a:r>
-                  <a:rPr lang="en-US" dirty="0"/>
-                  <a:t>.</a:t>
-                </a:r>
                 <a:br>
                   <a:rPr lang="en-US" dirty="0"/>
                 </a:br>
@@ -10441,7 +10574,7 @@
                         </a:solidFill>
                         <a:latin typeface="Cambria Math" panose="02040503050406030204" pitchFamily="18" charset="0"/>
                       </a:rPr>
-                      <m:t>h</m:t>
+                      <m:t>ℎ</m:t>
                     </m:r>
                     <m:r>
                       <a:rPr lang="en-US" i="1">
@@ -10548,7 +10681,7 @@
                 </a14:m>
                 <a:r>
                   <a:rPr lang="en-US" dirty="0"/>
-                  <a:t> is the </a:t>
+                  <a:t> is called the </a:t>
                 </a:r>
                 <a:r>
                   <a:rPr lang="en-US" dirty="0">
@@ -10566,7 +10699,7 @@
             </p:txBody>
           </p:sp>
         </mc:Choice>
-        <mc:Fallback xmlns="">
+        <mc:Fallback>
           <p:sp>
             <p:nvSpPr>
               <p:cNvPr id="8" name="Content Placeholder 7">
@@ -11071,7 +11204,7 @@
           <a:p>
             <a:r>
               <a:rPr lang="en-US" dirty="0"/>
-              <a:t>Despite claims to the contrary in the literature, it seems exceedingly unlikely to me that we can ever fully interpret what we are seeing in the latent.</a:t>
+              <a:t>Despite claims to the contrary in the literature, it seems exceedingly unlikely to me that we can ever fully interpret what we see in the latent space!</a:t>
             </a:r>
           </a:p>
         </p:txBody>
@@ -11673,8 +11806,8 @@
           </a:prstGeom>
         </p:spPr>
       </p:pic>
-      <mc:AlternateContent xmlns:mc="http://schemas.openxmlformats.org/markup-compatibility/2006" xmlns:a14="http://schemas.microsoft.com/office/drawing/2010/main">
-        <mc:Choice Requires="a14">
+      <mc:AlternateContent xmlns:mc="http://schemas.openxmlformats.org/markup-compatibility/2006">
+        <mc:Choice xmlns:a14="http://schemas.microsoft.com/office/drawing/2010/main" Requires="a14">
           <p:sp>
             <p:nvSpPr>
               <p:cNvPr id="8" name="Content Placeholder 7">
@@ -11807,7 +11940,7 @@
                         <a:ea typeface="Cambria Math" panose="02040503050406030204" pitchFamily="18" charset="0"/>
                         <a:cs typeface="Times New Roman" panose="02020603050405020304" pitchFamily="18" charset="0"/>
                       </a:rPr>
-                      <m:t>𝑁</m:t>
+                      <m:t>𝑑</m:t>
                     </m:r>
                   </m:oMath>
                 </a14:m>
@@ -11908,7 +12041,7 @@
                         </a:solidFill>
                         <a:latin typeface="Cambria Math" panose="02040503050406030204" pitchFamily="18" charset="0"/>
                       </a:rPr>
-                      <m:t>h</m:t>
+                      <m:t>ℎ</m:t>
                     </m:r>
                     <m:r>
                       <a:rPr lang="en-US" b="0" i="1" smtClean="0">
@@ -12198,7 +12331,7 @@
             </p:txBody>
           </p:sp>
         </mc:Choice>
-        <mc:Fallback xmlns="">
+        <mc:Fallback>
           <p:sp>
             <p:nvSpPr>
               <p:cNvPr id="8" name="Content Placeholder 7">
@@ -12427,7 +12560,7 @@
             </a:pPr>
             <a:r>
               <a:rPr lang="en-US" dirty="0"/>
-              <a:t>Our example this week focuses on </a:t>
+              <a:t>Our example focuses on </a:t>
             </a:r>
             <a:r>
               <a:rPr lang="en-US" dirty="0">
@@ -12773,8 +12906,8 @@
           </a:p>
         </p:txBody>
       </p:sp>
-      <mc:AlternateContent xmlns:mc="http://schemas.openxmlformats.org/markup-compatibility/2006" xmlns:a14="http://schemas.microsoft.com/office/drawing/2010/main">
-        <mc:Choice Requires="a14">
+      <mc:AlternateContent xmlns:mc="http://schemas.openxmlformats.org/markup-compatibility/2006">
+        <mc:Choice xmlns:a14="http://schemas.microsoft.com/office/drawing/2010/main" Requires="a14">
           <p:sp>
             <p:nvSpPr>
               <p:cNvPr id="8" name="Content Placeholder 7">
@@ -12931,7 +13064,7 @@
                             <a:latin typeface="Cambria Math" panose="02040503050406030204" pitchFamily="18" charset="0"/>
                             <a:ea typeface="Cambria Math" panose="02040503050406030204" pitchFamily="18" charset="0"/>
                           </a:rPr>
-                          <m:t>𝑁</m:t>
+                          <m:t>𝑑</m:t>
                         </m:r>
                       </m:sup>
                     </m:sSup>
@@ -13037,7 +13170,7 @@
                     <m:d>
                       <m:dPr>
                         <m:ctrlPr>
-                          <a:rPr lang="en-US" i="1">
+                          <a:rPr lang="en-US" b="0" i="1" smtClean="0">
                             <a:solidFill>
                               <a:srgbClr val="0033CC"/>
                             </a:solidFill>
@@ -13118,7 +13251,7 @@
                         <m:d>
                           <m:dPr>
                             <m:ctrlPr>
-                              <a:rPr lang="en-US" i="1">
+                              <a:rPr lang="en-US" b="0" i="1" smtClean="0">
                                 <a:solidFill>
                                   <a:srgbClr val="0033CC"/>
                                 </a:solidFill>
@@ -13238,10 +13371,7 @@
                 </a:pPr>
                 <a14:m>
                   <m:oMathPara xmlns:m="http://schemas.openxmlformats.org/officeDocument/2006/math">
-                    <m:oMathParaPr>
-                      <m:jc m:val="centerGroup"/>
-                    </m:oMathParaPr>
-                    <m:oMath xmlns:m="http://schemas.openxmlformats.org/officeDocument/2006/math">
+                    <m:oMath>
                       <m:nary>
                         <m:naryPr>
                           <m:limLoc m:val="undOvr"/>
@@ -13400,7 +13530,7 @@
             </p:txBody>
           </p:sp>
         </mc:Choice>
-        <mc:Fallback xmlns="">
+        <mc:Fallback>
           <p:sp>
             <p:nvSpPr>
               <p:cNvPr id="8" name="Content Placeholder 7">
@@ -13547,71 +13677,9 @@
                 <a:pPr marL="0" indent="0">
                   <a:buNone/>
                 </a:pPr>
-                <a:r>
-                  <a:rPr lang="en-US" dirty="0">
-                    <a:latin typeface="Times New Roman" panose="02020603050405020304" pitchFamily="18" charset="0"/>
-                    <a:cs typeface="Times New Roman" panose="02020603050405020304" pitchFamily="18" charset="0"/>
-                  </a:rPr>
-                  <a:t>Since, by assumption, the function </a:t>
-                </a:r>
-                <a14:m>
-                  <m:oMath xmlns:m="http://schemas.openxmlformats.org/officeDocument/2006/math">
-                    <m:r>
-                      <a:rPr lang="en-US" i="1" smtClean="0">
-                        <a:solidFill>
-                          <a:srgbClr val="0033CC"/>
-                        </a:solidFill>
-                        <a:latin typeface="Cambria Math" panose="02040503050406030204" pitchFamily="18" charset="0"/>
-                      </a:rPr>
-                      <m:t>𝑔</m:t>
-                    </m:r>
-                    <m:r>
-                      <a:rPr lang="en-US" i="1" smtClean="0">
-                        <a:solidFill>
-                          <a:srgbClr val="0033CC"/>
-                        </a:solidFill>
-                        <a:latin typeface="Cambria Math" panose="02040503050406030204" pitchFamily="18" charset="0"/>
-                      </a:rPr>
-                      <m:t>(</m:t>
-                    </m:r>
-                    <m:r>
-                      <a:rPr lang="en-US" i="1" smtClean="0">
-                        <a:solidFill>
-                          <a:srgbClr val="0033CC"/>
-                        </a:solidFill>
-                        <a:latin typeface="Cambria Math" panose="02040503050406030204" pitchFamily="18" charset="0"/>
-                      </a:rPr>
-                      <m:t>𝑥</m:t>
-                    </m:r>
-                    <m:r>
-                      <a:rPr lang="en-US" i="1" smtClean="0">
-                        <a:solidFill>
-                          <a:srgbClr val="0033CC"/>
-                        </a:solidFill>
-                        <a:latin typeface="Cambria Math" panose="02040503050406030204" pitchFamily="18" charset="0"/>
-                      </a:rPr>
-                      <m:t>)</m:t>
-                    </m:r>
-                  </m:oMath>
-                </a14:m>
-                <a:r>
-                  <a:rPr lang="en-US" dirty="0">
-                    <a:latin typeface="Times New Roman" panose="02020603050405020304" pitchFamily="18" charset="0"/>
-                    <a:cs typeface="Times New Roman" panose="02020603050405020304" pitchFamily="18" charset="0"/>
-                  </a:rPr>
-                  <a:t> is arbitrary, in</a:t>
-                </a:r>
-              </a:p>
-              <a:p>
-                <a:pPr marL="0" indent="0">
-                  <a:buNone/>
-                </a:pPr>
                 <a14:m>
                   <m:oMathPara xmlns:m="http://schemas.openxmlformats.org/officeDocument/2006/math">
-                    <m:oMathParaPr>
-                      <m:jc m:val="centerGroup"/>
-                    </m:oMathParaPr>
-                    <m:oMath xmlns:m="http://schemas.openxmlformats.org/officeDocument/2006/math">
+                    <m:oMath>
                       <m:nary>
                         <m:naryPr>
                           <m:limLoc m:val="undOvr"/>
@@ -13733,15 +13801,72 @@
                     </m:oMath>
                   </m:oMathPara>
                 </a14:m>
-                <a:endParaRPr lang="en-US" dirty="0"/>
+                <a:endParaRPr lang="en-US" dirty="0">
+                  <a:latin typeface="Times New Roman" panose="02020603050405020304" pitchFamily="18" charset="0"/>
+                  <a:cs typeface="Times New Roman" panose="02020603050405020304" pitchFamily="18" charset="0"/>
+                </a:endParaRPr>
               </a:p>
               <a:p>
                 <a:pPr marL="0" indent="0">
                   <a:buNone/>
                 </a:pPr>
                 <a:r>
+                  <a:rPr lang="en-US" dirty="0">
+                    <a:latin typeface="Times New Roman" panose="02020603050405020304" pitchFamily="18" charset="0"/>
+                    <a:cs typeface="Times New Roman" panose="02020603050405020304" pitchFamily="18" charset="0"/>
+                  </a:rPr>
+                  <a:t>Since, by assumption, the function </a:t>
+                </a:r>
+                <a14:m>
+                  <m:oMath xmlns:m="http://schemas.openxmlformats.org/officeDocument/2006/math">
+                    <m:r>
+                      <a:rPr lang="en-US" i="1" smtClean="0">
+                        <a:solidFill>
+                          <a:srgbClr val="0033CC"/>
+                        </a:solidFill>
+                        <a:latin typeface="Cambria Math" panose="02040503050406030204" pitchFamily="18" charset="0"/>
+                      </a:rPr>
+                      <m:t>𝑔</m:t>
+                    </m:r>
+                    <m:r>
+                      <a:rPr lang="en-US" i="1" smtClean="0">
+                        <a:solidFill>
+                          <a:srgbClr val="0033CC"/>
+                        </a:solidFill>
+                        <a:latin typeface="Cambria Math" panose="02040503050406030204" pitchFamily="18" charset="0"/>
+                      </a:rPr>
+                      <m:t>(</m:t>
+                    </m:r>
+                    <m:r>
+                      <a:rPr lang="en-US" i="1" smtClean="0">
+                        <a:solidFill>
+                          <a:srgbClr val="0033CC"/>
+                        </a:solidFill>
+                        <a:latin typeface="Cambria Math" panose="02040503050406030204" pitchFamily="18" charset="0"/>
+                      </a:rPr>
+                      <m:t>𝑥</m:t>
+                    </m:r>
+                    <m:r>
+                      <a:rPr lang="en-US" i="1" smtClean="0">
+                        <a:solidFill>
+                          <a:srgbClr val="0033CC"/>
+                        </a:solidFill>
+                        <a:latin typeface="Cambria Math" panose="02040503050406030204" pitchFamily="18" charset="0"/>
+                      </a:rPr>
+                      <m:t>)</m:t>
+                    </m:r>
+                  </m:oMath>
+                </a14:m>
+                <a:r>
+                  <a:rPr lang="en-US" dirty="0">
+                    <a:latin typeface="Times New Roman" panose="02020603050405020304" pitchFamily="18" charset="0"/>
+                    <a:cs typeface="Times New Roman" panose="02020603050405020304" pitchFamily="18" charset="0"/>
+                  </a:rPr>
+                  <a:t> is arbitrary (and assuming</a:t>
+                </a:r>
+                <a:r>
                   <a:rPr lang="en-US" dirty="0"/>
-                  <a:t>if </a:t>
+                  <a:t> </a:t>
                 </a:r>
                 <a14:m>
                   <m:oMath xmlns:m="http://schemas.openxmlformats.org/officeDocument/2006/math">
@@ -13799,7 +13924,7 @@
                 </a14:m>
                 <a:r>
                   <a:rPr lang="en-US" dirty="0"/>
-                  <a:t>, the equality will hold </a:t>
+                  <a:t>) the above will hold </a:t>
                 </a:r>
                 <a:r>
                   <a:rPr lang="en-US" i="1" dirty="0"/>
@@ -13815,10 +13940,7 @@
                 </a:pPr>
                 <a14:m>
                   <m:oMathPara xmlns:m="http://schemas.openxmlformats.org/officeDocument/2006/math">
-                    <m:oMathParaPr>
-                      <m:jc m:val="centerGroup"/>
-                    </m:oMathParaPr>
-                    <m:oMath xmlns:m="http://schemas.openxmlformats.org/officeDocument/2006/math">
+                    <m:oMath>
                       <m:f>
                         <m:fPr>
                           <m:ctrlPr>
@@ -14039,12 +14161,50 @@
                 </a:pPr>
                 <a14:m>
                   <m:oMath xmlns:m="http://schemas.openxmlformats.org/officeDocument/2006/math">
-                    <m:r>
-                      <a:rPr lang="en-US" i="1" dirty="0" smtClean="0">
-                        <a:latin typeface="Cambria Math" panose="02040503050406030204" pitchFamily="18" charset="0"/>
-                      </a:rPr>
-                      <m:t>𝑓</m:t>
-                    </m:r>
+                    <m:sSub>
+                      <m:sSubPr>
+                        <m:ctrlPr>
+                          <a:rPr lang="en-US" b="0" i="1" dirty="0" smtClean="0">
+                            <a:latin typeface="Cambria Math" panose="02040503050406030204" pitchFamily="18" charset="0"/>
+                          </a:rPr>
+                        </m:ctrlPr>
+                      </m:sSubPr>
+                      <m:e>
+                        <m:r>
+                          <a:rPr lang="en-US" b="0" i="1" dirty="0" smtClean="0">
+                            <a:latin typeface="Cambria Math" panose="02040503050406030204" pitchFamily="18" charset="0"/>
+                          </a:rPr>
+                          <m:t>𝑓</m:t>
+                        </m:r>
+                      </m:e>
+                      <m:sub>
+                        <m:sSup>
+                          <m:sSupPr>
+                            <m:ctrlPr>
+                              <a:rPr lang="en-US" b="0" i="1" dirty="0" smtClean="0">
+                                <a:latin typeface="Cambria Math" panose="02040503050406030204" pitchFamily="18" charset="0"/>
+                              </a:rPr>
+                            </m:ctrlPr>
+                          </m:sSupPr>
+                          <m:e>
+                            <m:r>
+                              <a:rPr lang="en-US" b="0" i="1" dirty="0" smtClean="0">
+                                <a:latin typeface="Cambria Math" panose="02040503050406030204" pitchFamily="18" charset="0"/>
+                              </a:rPr>
+                              <m:t>𝜔</m:t>
+                            </m:r>
+                          </m:e>
+                          <m:sup>
+                            <m:r>
+                              <a:rPr lang="en-US" b="0" i="1" dirty="0" smtClean="0">
+                                <a:latin typeface="Cambria Math" panose="02040503050406030204" pitchFamily="18" charset="0"/>
+                              </a:rPr>
+                              <m:t>∗</m:t>
+                            </m:r>
+                          </m:sup>
+                        </m:sSup>
+                      </m:sub>
+                    </m:sSub>
                     <m:r>
                       <a:rPr lang="en-US" i="1" dirty="0" smtClean="0">
                         <a:latin typeface="Cambria Math" panose="02040503050406030204" pitchFamily="18" charset="0"/>
@@ -14057,37 +14217,6 @@
                       </a:rPr>
                       <m:t>𝑥</m:t>
                     </m:r>
-                    <m:r>
-                      <a:rPr lang="en-US" i="1" dirty="0" smtClean="0">
-                        <a:latin typeface="Cambria Math" panose="02040503050406030204" pitchFamily="18" charset="0"/>
-                      </a:rPr>
-                      <m:t>, </m:t>
-                    </m:r>
-                    <m:sSup>
-                      <m:sSupPr>
-                        <m:ctrlPr>
-                          <a:rPr lang="en-US" i="1" dirty="0">
-                            <a:latin typeface="Cambria Math" panose="02040503050406030204" pitchFamily="18" charset="0"/>
-                          </a:rPr>
-                        </m:ctrlPr>
-                      </m:sSupPr>
-                      <m:e>
-                        <m:r>
-                          <a:rPr lang="en-US" i="1" dirty="0">
-                            <a:latin typeface="Cambria Math" panose="02040503050406030204" pitchFamily="18" charset="0"/>
-                          </a:rPr>
-                          <m:t>𝜔</m:t>
-                        </m:r>
-                      </m:e>
-                      <m:sup>
-                        <m:r>
-                          <a:rPr lang="en-US" i="1" dirty="0">
-                            <a:latin typeface="Cambria Math" panose="02040503050406030204" pitchFamily="18" charset="0"/>
-                          </a:rPr>
-                          <m:t>∗</m:t>
-                        </m:r>
-                      </m:sup>
-                    </m:sSup>
                     <m:r>
                       <a:rPr lang="en-US" i="1" dirty="0">
                         <a:latin typeface="Cambria Math" panose="02040503050406030204" pitchFamily="18" charset="0"/>
@@ -14162,7 +14291,7 @@
               <a:blipFill>
                 <a:blip r:embed="rId2"/>
                 <a:stretch>
-                  <a:fillRect l="-1305" t="-23421" r="-2121"/>
+                  <a:fillRect l="-1305" t="-31053" r="-2121"/>
                 </a:stretch>
               </a:blipFill>
             </p:spPr>
@@ -14508,7 +14637,7 @@
           <a:p>
             <a:r>
               <a:rPr lang="en-US" dirty="0"/>
-              <a:t>We’ll use an autoencoder </a:t>
+              <a:t>The autoencoder will be</a:t>
             </a:r>
           </a:p>
           <a:p>
@@ -14517,7 +14646,7 @@
             </a:pPr>
             <a:r>
               <a:rPr lang="en-US" dirty="0"/>
-              <a:t>     to search for structure in</a:t>
+              <a:t>     used to search for structure in</a:t>
             </a:r>
           </a:p>
           <a:p>

</xml_diff>